<commit_message>
fix: update job metadata and word count tracking
Update checkpoint files for jobs 170 and 'a' to reflect accurate total word counts and resolve warning states after document processing.
</commit_message>
<xml_diff>
--- a/jobs_storage/job_pptx/output/presentation_6_FA.pptx
+++ b/jobs_storage/job_pptx/output/presentation_6_FA.pptx
@@ -6,8 +6,10 @@
       <p:sp>
         <p:txBody>
           <a:p>
+            <a:pPr rtl="1" algn="r"/>
             <a:r>
-              <a:t>[ترجمه]: Slide 1 Strategic Roadmap</a:t>
+              <a:rPr lang="fa-IR" altLang="en-US"/>
+              <a:t>اسلاید ۱ نقشه راه استراتژیک</a:t>
             </a:r>
           </a:p>
         </p:txBody>
@@ -24,8 +26,10 @@
       <p:sp>
         <p:txBody>
           <a:p>
+            <a:pPr rtl="1" algn="r"/>
             <a:r>
-              <a:t>[ترجمه]: Slide 2 Strategic Roadmap</a:t>
+              <a:rPr lang="fa-IR" altLang="en-US"/>
+              <a:t>اسلاید ۲ نقشه راه استراتژیک</a:t>
             </a:r>
           </a:p>
         </p:txBody>
@@ -42,8 +46,10 @@
       <p:sp>
         <p:txBody>
           <a:p>
+            <a:pPr rtl="1" algn="r"/>
             <a:r>
-              <a:t>[ترجمه]: Slide 3 Strategic Roadmap</a:t>
+              <a:rPr lang="fa-IR" altLang="en-US"/>
+              <a:t>اسلاید 3 نقشه راه استراتژیک</a:t>
             </a:r>
           </a:p>
         </p:txBody>
@@ -60,8 +66,10 @@
       <p:sp>
         <p:txBody>
           <a:p>
+            <a:pPr rtl="1" algn="r"/>
             <a:r>
-              <a:t>[ترجمه]: Slide 4 Strategic Roadmap</a:t>
+              <a:rPr lang="fa-IR" altLang="en-US"/>
+              <a:t>اسلاید 4 نقشه راه استراتژیک</a:t>
             </a:r>
           </a:p>
         </p:txBody>
@@ -78,8 +86,10 @@
       <p:sp>
         <p:txBody>
           <a:p>
+            <a:pPr rtl="1" algn="r"/>
             <a:r>
-              <a:t>[ترجمه]: Slide 5 Strategic Roadmap</a:t>
+              <a:rPr lang="fa-IR" altLang="en-US"/>
+              <a:t>اسلاید ۵ نقشه راه استراتژیک</a:t>
             </a:r>
           </a:p>
         </p:txBody>
@@ -96,8 +106,10 @@
       <p:sp>
         <p:txBody>
           <a:p>
+            <a:pPr rtl="1" algn="r"/>
             <a:r>
-              <a:t>[ترجمه]: Slide 6 Strategic Roadmap</a:t>
+              <a:rPr lang="fa-IR" altLang="en-US"/>
+              <a:t>اسلاید 6 نقشه راه استراتژیک</a:t>
             </a:r>
           </a:p>
         </p:txBody>

</xml_diff>